<commit_message>
Wrap long table labels and widen caption/bullet gap; add table split option
- render_hier_table_image now wraps long row/column header labels
  (e.g. "Figueira da Foz") onto multiple lines instead of overflowing
  their cell border.
- Widened the gap between equation/diagram captions and the bullet
  list below them on content slides (3-11).
- New --results-table-split {strategy,constructor,improver} flag:
  partitions the full-results table by that column-hierarchy level,
  stacking one labeled partial table per value on the slide instead
  of one very wide table.
- Regenerated the deck with --results-table-split improver.

Co-Authored-By: Claude Sonnet 5 <noreply@anthropic.com>
Claude-Session: https://claude.ai/code/session_01PirA47B8vEdSjyiM4U4Z21
</commit_message>
<xml_diff>
--- a/assets/windows/wsmart_route_results.pptx
+++ b/assets/windows/wsmart_route_results.pptx
@@ -3461,8 +3461,8 @@
         </p:nvSpPr>
         <p:spPr>
           <a:xfrm>
-            <a:off x="548640" y="3794760"/>
-            <a:ext cx="11094415" cy="2697480"/>
+            <a:off x="548640" y="4114800"/>
+            <a:ext cx="11094415" cy="2377440"/>
           </a:xfrm>
           <a:prstGeom prst="rect">
             <a:avLst/>
@@ -3723,8 +3723,8 @@
         </p:nvSpPr>
         <p:spPr>
           <a:xfrm>
-            <a:off x="548640" y="3794760"/>
-            <a:ext cx="11094415" cy="2697480"/>
+            <a:off x="548640" y="4114800"/>
+            <a:ext cx="11094415" cy="2377440"/>
           </a:xfrm>
           <a:prstGeom prst="rect">
             <a:avLst/>
@@ -4591,9 +4591,44 @@
           </a:p>
         </p:txBody>
       </p:sp>
+      <p:sp>
+        <p:nvSpPr>
+          <p:cNvPr id="3" name="TextBox 2"/>
+          <p:cNvSpPr txBox="1"/>
+          <p:nvPr/>
+        </p:nvSpPr>
+        <p:spPr>
+          <a:xfrm>
+            <a:off x="365760" y="1051560"/>
+            <a:ext cx="11460175" cy="274320"/>
+          </a:xfrm>
+          <a:prstGeom prst="rect">
+            <a:avLst/>
+          </a:prstGeom>
+          <a:noFill/>
+        </p:spPr>
+        <p:txBody>
+          <a:bodyPr wrap="square">
+            <a:spAutoFit/>
+          </a:bodyPr>
+          <a:lstStyle/>
+          <a:p>
+            <a:pPr>
+              <a:defRPr b="1" sz="1200">
+                <a:solidFill>
+                  <a:srgbClr val="2E74B5"/>
+                </a:solidFill>
+              </a:defRPr>
+            </a:pPr>
+            <a:r>
+              <a:t>Improver: FTSP</a:t>
+            </a:r>
+          </a:p>
+        </p:txBody>
+      </p:sp>
       <p:pic>
         <p:nvPicPr>
-          <p:cNvPr id="3" name="Picture 2" descr="full_results_table.png"/>
+          <p:cNvPr id="4" name="Picture 3" descr="full_results_table_improver_0.png"/>
           <p:cNvPicPr>
             <a:picLocks noChangeAspect="1"/>
           </p:cNvPicPr>
@@ -4607,8 +4642,8 @@
         </p:blipFill>
         <p:spPr>
           <a:xfrm>
-            <a:off x="274320" y="2869653"/>
-            <a:ext cx="11643055" cy="1301573"/>
+            <a:off x="274320" y="1579833"/>
+            <a:ext cx="11643055" cy="1677509"/>
           </a:xfrm>
           <a:prstGeom prst="rect">
             <a:avLst/>
@@ -4617,14 +4652,14 @@
       </p:pic>
       <p:sp>
         <p:nvSpPr>
-          <p:cNvPr id="4" name="TextBox 3"/>
+          <p:cNvPr id="5" name="TextBox 4"/>
           <p:cNvSpPr txBox="1"/>
           <p:nvPr/>
         </p:nvSpPr>
         <p:spPr>
           <a:xfrm>
-            <a:off x="548640" y="6355080"/>
-            <a:ext cx="11094415" cy="548640"/>
+            <a:off x="365760" y="3520440"/>
+            <a:ext cx="11460175" cy="274320"/>
           </a:xfrm>
           <a:prstGeom prst="rect">
             <a:avLst/>
@@ -4637,6 +4672,65 @@
           </a:bodyPr>
           <a:lstStyle/>
           <a:p>
+            <a:pPr>
+              <a:defRPr b="1" sz="1200">
+                <a:solidFill>
+                  <a:srgbClr val="2E74B5"/>
+                </a:solidFill>
+              </a:defRPr>
+            </a:pPr>
+            <a:r>
+              <a:t>Improver: CLS</a:t>
+            </a:r>
+          </a:p>
+        </p:txBody>
+      </p:sp>
+      <p:pic>
+        <p:nvPicPr>
+          <p:cNvPr id="6" name="Picture 5" descr="full_results_table_improver_1.png"/>
+          <p:cNvPicPr>
+            <a:picLocks noChangeAspect="1"/>
+          </p:cNvPicPr>
+          <p:nvPr/>
+        </p:nvPicPr>
+        <p:blipFill>
+          <a:blip r:embed="rId3"/>
+          <a:stretch>
+            <a:fillRect/>
+          </a:stretch>
+        </p:blipFill>
+        <p:spPr>
+          <a:xfrm>
+            <a:off x="274320" y="4048713"/>
+            <a:ext cx="11643055" cy="1677509"/>
+          </a:xfrm>
+          <a:prstGeom prst="rect">
+            <a:avLst/>
+          </a:prstGeom>
+        </p:spPr>
+      </p:pic>
+      <p:sp>
+        <p:nvSpPr>
+          <p:cNvPr id="7" name="TextBox 6"/>
+          <p:cNvSpPr txBox="1"/>
+          <p:nvPr/>
+        </p:nvSpPr>
+        <p:spPr>
+          <a:xfrm>
+            <a:off x="548640" y="6355080"/>
+            <a:ext cx="11094415" cy="548640"/>
+          </a:xfrm>
+          <a:prstGeom prst="rect">
+            <a:avLst/>
+          </a:prstGeom>
+          <a:noFill/>
+        </p:spPr>
+        <p:txBody>
+          <a:bodyPr wrap="square">
+            <a:spAutoFit/>
+          </a:bodyPr>
+          <a:lstStyle/>
+          <a:p>
             <a:r>
               <a:rPr b="1" sz="1100">
                 <a:solidFill>
@@ -4651,7 +4745,7 @@
                   <a:srgbClr val="5A6A7A"/>
                 </a:solidFill>
               </a:rPr>
-              <a:t>Full results table — rows: graph size × region × data distribution; columns: mandatory selection strategy × route constructor × route improver. Each cell reports mean±std overflows and mean±std kg/km.</a:t>
+              <a:t>Full results table — rows: graph size × region × data distribution; columns: partitioned by route improver (FTSP, CLS), one partial table per value; each partial table then grouped by mandatory selection strategy × route constructor. Each cell reports mean±std overflows and mean±std kg/km.</a:t>
             </a:r>
           </a:p>
         </p:txBody>
@@ -5537,8 +5631,8 @@
         </p:nvSpPr>
         <p:spPr>
           <a:xfrm>
-            <a:off x="548640" y="3794760"/>
-            <a:ext cx="11094415" cy="2697480"/>
+            <a:off x="548640" y="4114800"/>
+            <a:ext cx="11094415" cy="2377440"/>
           </a:xfrm>
           <a:prstGeom prst="rect">
             <a:avLst/>
@@ -6232,8 +6326,8 @@
         </p:nvSpPr>
         <p:spPr>
           <a:xfrm>
-            <a:off x="548640" y="5486400"/>
-            <a:ext cx="11094415" cy="1005840"/>
+            <a:off x="548640" y="5806440"/>
+            <a:ext cx="11094415" cy="685800"/>
           </a:xfrm>
           <a:prstGeom prst="rect">
             <a:avLst/>
@@ -6464,8 +6558,8 @@
         </p:nvSpPr>
         <p:spPr>
           <a:xfrm>
-            <a:off x="548640" y="4480560"/>
-            <a:ext cx="11094415" cy="2011680"/>
+            <a:off x="548640" y="4800600"/>
+            <a:ext cx="11094415" cy="1691640"/>
           </a:xfrm>
           <a:prstGeom prst="rect">
             <a:avLst/>
@@ -6711,8 +6805,8 @@
         </p:nvSpPr>
         <p:spPr>
           <a:xfrm>
-            <a:off x="548640" y="3108960"/>
-            <a:ext cx="11094415" cy="3383280"/>
+            <a:off x="548640" y="3429000"/>
+            <a:ext cx="11094415" cy="3063240"/>
           </a:xfrm>
           <a:prstGeom prst="rect">
             <a:avLst/>
@@ -6973,8 +7067,8 @@
         </p:nvSpPr>
         <p:spPr>
           <a:xfrm>
-            <a:off x="548640" y="3794760"/>
-            <a:ext cx="11094415" cy="2697480"/>
+            <a:off x="548640" y="4114800"/>
+            <a:ext cx="11094415" cy="2377440"/>
           </a:xfrm>
           <a:prstGeom prst="rect">
             <a:avLst/>
@@ -7235,8 +7329,8 @@
         </p:nvSpPr>
         <p:spPr>
           <a:xfrm>
-            <a:off x="548640" y="3108960"/>
-            <a:ext cx="11094415" cy="3383280"/>
+            <a:off x="548640" y="3429000"/>
+            <a:ext cx="11094415" cy="3063240"/>
           </a:xfrm>
           <a:prstGeom prst="rect">
             <a:avLst/>
@@ -7497,8 +7591,8 @@
         </p:nvSpPr>
         <p:spPr>
           <a:xfrm>
-            <a:off x="548640" y="3794760"/>
-            <a:ext cx="11094415" cy="2697480"/>
+            <a:off x="548640" y="4114800"/>
+            <a:ext cx="11094415" cy="2377440"/>
           </a:xfrm>
           <a:prstGeom prst="rect">
             <a:avLst/>

</xml_diff>

<commit_message>
feat(presentation): update Q&A slide route illustration and slide 15 legend layout
- Generate a VRP with Profits route illustration with multiple colored routes, unvisited nodes, and a marked depot for the Q&A slide.
- Relocate the shared axis labels on slide 15 (scenario heatmaps) to the bottom to allow full-width figures.
- Re-generated the PowerPoint presentation.

Co-authored-by: Gemini Code Assist <gemini-code-assist@google.com>
</commit_message>
<xml_diff>
--- a/assets/windows/wsmart_route_results.pptx
+++ b/assets/windows/wsmart_route_results.pptx
@@ -5475,8 +5475,8 @@
         </p:blipFill>
         <p:spPr>
           <a:xfrm>
-            <a:off x="274320" y="1226724"/>
-            <a:ext cx="8442655" cy="4770311"/>
+            <a:off x="2929570" y="1051560"/>
+            <a:ext cx="6149674" cy="3474720"/>
           </a:xfrm>
           <a:prstGeom prst="rect">
             <a:avLst/>
@@ -5491,8 +5491,8 @@
         </p:nvSpPr>
         <p:spPr>
           <a:xfrm>
-            <a:off x="9082735" y="1051560"/>
-            <a:ext cx="2834640" cy="5120640"/>
+            <a:off x="274320" y="4663440"/>
+            <a:ext cx="11643055" cy="1005840"/>
           </a:xfrm>
           <a:prstGeom prst="roundRect">
             <a:avLst/>
@@ -5535,8 +5535,8 @@
         </p:nvSpPr>
         <p:spPr>
           <a:xfrm>
-            <a:off x="9265615" y="1188720"/>
-            <a:ext cx="2468880" cy="4846320"/>
+            <a:off x="457200" y="4754880"/>
+            <a:ext cx="11277295" cy="822960"/>
           </a:xfrm>
           <a:prstGeom prst="rect">
             <a:avLst/>
@@ -5550,7 +5550,7 @@
           <a:lstStyle/>
           <a:p>
             <a:pPr>
-              <a:defRPr sz="1400" b="1">
+              <a:defRPr sz="1300" b="1">
                 <a:solidFill>
                   <a:srgbClr val="2E74B5"/>
                 </a:solidFill>
@@ -5563,9 +5563,9 @@
           <a:p>
             <a:pPr>
               <a:spcBef>
-                <a:spcPts val="1000"/>
+                <a:spcPts val="300"/>
               </a:spcBef>
-              <a:defRPr sz="1200">
+              <a:defRPr sz="1050">
                 <a:solidFill>
                   <a:srgbClr val="1F2D3D"/>
                 </a:solidFill>
@@ -5578,9 +5578,9 @@
           <a:p>
             <a:pPr>
               <a:spcBef>
-                <a:spcPts val="1000"/>
+                <a:spcPts val="300"/>
               </a:spcBef>
-              <a:defRPr sz="1200">
+              <a:defRPr sz="1050">
                 <a:solidFill>
                   <a:srgbClr val="1F2D3D"/>
                 </a:solidFill>
@@ -5593,9 +5593,9 @@
           <a:p>
             <a:pPr>
               <a:spcBef>
-                <a:spcPts val="1000"/>
+                <a:spcPts val="300"/>
               </a:spcBef>
-              <a:defRPr sz="1200">
+              <a:defRPr sz="1050">
                 <a:solidFill>
                   <a:srgbClr val="1F2D3D"/>
                 </a:solidFill>
@@ -5615,7 +5615,7 @@
         </p:nvSpPr>
         <p:spPr>
           <a:xfrm>
-            <a:off x="548640" y="6355080"/>
+            <a:off x="548640" y="6263640"/>
             <a:ext cx="11094415" cy="822960"/>
           </a:xfrm>
           <a:prstGeom prst="rect">
@@ -6012,44 +6012,9 @@
           </a:p>
         </p:txBody>
       </p:sp>
-      <p:sp>
-        <p:nvSpPr>
-          <p:cNvPr id="3" name="TextBox 2"/>
-          <p:cNvSpPr txBox="1"/>
-          <p:nvPr/>
-        </p:nvSpPr>
-        <p:spPr>
-          <a:xfrm>
-            <a:off x="365760" y="1051560"/>
-            <a:ext cx="11460175" cy="274320"/>
-          </a:xfrm>
-          <a:prstGeom prst="rect">
-            <a:avLst/>
-          </a:prstGeom>
-          <a:noFill/>
-        </p:spPr>
-        <p:txBody>
-          <a:bodyPr wrap="square">
-            <a:spAutoFit/>
-          </a:bodyPr>
-          <a:lstStyle/>
-          <a:p>
-            <a:pPr>
-              <a:defRPr b="1" sz="1200">
-                <a:solidFill>
-                  <a:srgbClr val="2E74B5"/>
-                </a:solidFill>
-              </a:defRPr>
-            </a:pPr>
-            <a:r>
-              <a:t>Improver: FTSP</a:t>
-            </a:r>
-          </a:p>
-        </p:txBody>
-      </p:sp>
       <p:pic>
         <p:nvPicPr>
-          <p:cNvPr id="4" name="Picture 3" descr="full_results_table_improver_0.png"/>
+          <p:cNvPr id="3" name="Picture 2" descr="full_results_table.png"/>
           <p:cNvPicPr>
             <a:picLocks noChangeAspect="1"/>
           </p:cNvPicPr>
@@ -6063,8 +6028,8 @@
         </p:blipFill>
         <p:spPr>
           <a:xfrm>
-            <a:off x="274320" y="1579833"/>
-            <a:ext cx="11643055" cy="1677509"/>
+            <a:off x="274320" y="2869653"/>
+            <a:ext cx="11643055" cy="1301573"/>
           </a:xfrm>
           <a:prstGeom prst="rect">
             <a:avLst/>
@@ -6073,14 +6038,14 @@
       </p:pic>
       <p:sp>
         <p:nvSpPr>
-          <p:cNvPr id="5" name="TextBox 4"/>
+          <p:cNvPr id="4" name="TextBox 3"/>
           <p:cNvSpPr txBox="1"/>
           <p:nvPr/>
         </p:nvSpPr>
         <p:spPr>
           <a:xfrm>
-            <a:off x="365760" y="3520440"/>
-            <a:ext cx="11460175" cy="274320"/>
+            <a:off x="548640" y="6355080"/>
+            <a:ext cx="11094415" cy="822960"/>
           </a:xfrm>
           <a:prstGeom prst="rect">
             <a:avLst/>
@@ -6093,65 +6058,6 @@
           </a:bodyPr>
           <a:lstStyle/>
           <a:p>
-            <a:pPr>
-              <a:defRPr b="1" sz="1200">
-                <a:solidFill>
-                  <a:srgbClr val="2E74B5"/>
-                </a:solidFill>
-              </a:defRPr>
-            </a:pPr>
-            <a:r>
-              <a:t>Improver: CLS</a:t>
-            </a:r>
-          </a:p>
-        </p:txBody>
-      </p:sp>
-      <p:pic>
-        <p:nvPicPr>
-          <p:cNvPr id="6" name="Picture 5" descr="full_results_table_improver_1.png"/>
-          <p:cNvPicPr>
-            <a:picLocks noChangeAspect="1"/>
-          </p:cNvPicPr>
-          <p:nvPr/>
-        </p:nvPicPr>
-        <p:blipFill>
-          <a:blip r:embed="rId3"/>
-          <a:stretch>
-            <a:fillRect/>
-          </a:stretch>
-        </p:blipFill>
-        <p:spPr>
-          <a:xfrm>
-            <a:off x="274320" y="4048713"/>
-            <a:ext cx="11643055" cy="1677509"/>
-          </a:xfrm>
-          <a:prstGeom prst="rect">
-            <a:avLst/>
-          </a:prstGeom>
-        </p:spPr>
-      </p:pic>
-      <p:sp>
-        <p:nvSpPr>
-          <p:cNvPr id="7" name="TextBox 6"/>
-          <p:cNvSpPr txBox="1"/>
-          <p:nvPr/>
-        </p:nvSpPr>
-        <p:spPr>
-          <a:xfrm>
-            <a:off x="548640" y="6355080"/>
-            <a:ext cx="11094415" cy="822960"/>
-          </a:xfrm>
-          <a:prstGeom prst="rect">
-            <a:avLst/>
-          </a:prstGeom>
-          <a:noFill/>
-        </p:spPr>
-        <p:txBody>
-          <a:bodyPr wrap="square">
-            <a:spAutoFit/>
-          </a:bodyPr>
-          <a:lstStyle/>
-          <a:p>
             <a:r>
               <a:rPr b="1" sz="1100">
                 <a:solidFill>
@@ -6166,7 +6072,7 @@
                   <a:srgbClr val="5A6A7A"/>
                 </a:solidFill>
               </a:rPr>
-              <a:t>Full results table — rows: graph size × region × data distribution; columns: partitioned by route improver (FTSP, CLS), one partial table per value; each partial table then grouped by mandatory selection strategy × route constructor. In every cell, the top value is mean±std overflows (lower is better) and the bottom value is mean±std kg/km (higher is better); the best value per row is shown in bold green.</a:t>
+              <a:t>Full results table — rows: graph size × region × data distribution; columns: mandatory selection strategy × route constructor × route improver. In every cell, the top value is mean±std overflows (lower is better) and the bottom value is mean±std kg/km (higher is better); the best value per row is shown in bold green.</a:t>
             </a:r>
           </a:p>
         </p:txBody>
@@ -6717,7 +6623,7 @@
       </p:sp>
       <p:pic>
         <p:nvPicPr>
-          <p:cNvPr id="4" name="Picture 3" descr="policy_radar_combined.png"/>
+          <p:cNvPr id="4" name="Picture 3" descr="qa_route_illustration.png"/>
           <p:cNvPicPr>
             <a:picLocks noChangeAspect="1"/>
           </p:cNvPicPr>
@@ -6731,8 +6637,8 @@
         </p:blipFill>
         <p:spPr>
           <a:xfrm>
-            <a:off x="6278727" y="1216397"/>
-            <a:ext cx="5364327" cy="4425206"/>
+            <a:off x="6278727" y="717978"/>
+            <a:ext cx="5364327" cy="5422044"/>
           </a:xfrm>
           <a:prstGeom prst="rect">
             <a:avLst/>

</xml_diff>

<commit_message>
feat(presentation): light-theme figures, full-width split table with in-table strategy labels
- Regenerate all 30-day simulation figures with light background (--theme light).
- Adjust scenario constructor heatmap figsize height to 7.2 for better slide 15 aspect ratio.
- Fix slide 18 split table: remove separate 'Strategy: X' textboxes; embed the strategy
  acronym directly as a full-width dark banner row at the top of each table image via the
  new 'partition_label' parameter in render_hier_table_image.
- Each split table now occupies the full slide width without any label offset.

Co-authored-by: Gemini Code Assist <gemini-code-assist@google.com>
</commit_message>
<xml_diff>
--- a/assets/windows/wsmart_route_results.pptx
+++ b/assets/windows/wsmart_route_results.pptx
@@ -5063,7 +5063,7 @@
         <p:spPr>
           <a:xfrm>
             <a:off x="548640" y="6355080"/>
-            <a:ext cx="11094415" cy="822960"/>
+            <a:ext cx="11643055" cy="822960"/>
           </a:xfrm>
           <a:prstGeom prst="rect">
             <a:avLst/>
@@ -5222,7 +5222,7 @@
         <p:spPr>
           <a:xfrm>
             <a:off x="548640" y="6355080"/>
-            <a:ext cx="11094415" cy="822960"/>
+            <a:ext cx="11643055" cy="822960"/>
           </a:xfrm>
           <a:prstGeom prst="rect">
             <a:avLst/>
@@ -5357,7 +5357,7 @@
         <p:spPr>
           <a:xfrm>
             <a:off x="548640" y="6355080"/>
-            <a:ext cx="11094415" cy="822960"/>
+            <a:ext cx="11643055" cy="822960"/>
           </a:xfrm>
           <a:prstGeom prst="rect">
             <a:avLst/>
@@ -5475,8 +5475,8 @@
         </p:blipFill>
         <p:spPr>
           <a:xfrm>
-            <a:off x="2929570" y="1051560"/>
-            <a:ext cx="6149674" cy="3474720"/>
+            <a:off x="274320" y="1172366"/>
+            <a:ext cx="11460175" cy="3598867"/>
           </a:xfrm>
           <a:prstGeom prst="rect">
             <a:avLst/>
@@ -5485,14 +5485,55 @@
       </p:pic>
       <p:sp>
         <p:nvSpPr>
-          <p:cNvPr id="4" name="Rounded Rectangle 3"/>
+          <p:cNvPr id="4" name="TextBox 3"/>
+          <p:cNvSpPr txBox="1"/>
+          <p:nvPr/>
+        </p:nvSpPr>
+        <p:spPr>
+          <a:xfrm>
+            <a:off x="548640" y="4937760"/>
+            <a:ext cx="11643055" cy="320040"/>
+          </a:xfrm>
+          <a:prstGeom prst="rect">
+            <a:avLst/>
+          </a:prstGeom>
+          <a:noFill/>
+        </p:spPr>
+        <p:txBody>
+          <a:bodyPr wrap="square">
+            <a:spAutoFit/>
+          </a:bodyPr>
+          <a:lstStyle/>
+          <a:p>
+            <a:r>
+              <a:rPr b="1" sz="1100">
+                <a:solidFill>
+                  <a:srgbClr val="1F2D3D"/>
+                </a:solidFill>
+              </a:rPr>
+              <a:t>Figure 7: </a:t>
+            </a:r>
+            <a:r>
+              <a:rPr i="1" sz="1100">
+                <a:solidFill>
+                  <a:srgbClr val="5A6A7A"/>
+                </a:solidFill>
+              </a:rPr>
+              <a:t>30-day runs. One panel per scenario; route constructors on the rows, selection × improver combinations on the columns.</a:t>
+            </a:r>
+          </a:p>
+        </p:txBody>
+      </p:sp>
+      <p:sp>
+        <p:nvSpPr>
+          <p:cNvPr id="5" name="Rounded Rectangle 4"/>
           <p:cNvSpPr/>
           <p:nvPr/>
         </p:nvSpPr>
         <p:spPr>
           <a:xfrm>
-            <a:off x="274320" y="4663440"/>
-            <a:ext cx="11643055" cy="1005840"/>
+            <a:off x="274320" y="5303520"/>
+            <a:ext cx="11643055" cy="1188720"/>
           </a:xfrm>
           <a:prstGeom prst="roundRect">
             <a:avLst/>
@@ -5529,14 +5570,14 @@
       </p:sp>
       <p:sp>
         <p:nvSpPr>
-          <p:cNvPr id="5" name="TextBox 4"/>
+          <p:cNvPr id="6" name="TextBox 5"/>
           <p:cNvSpPr txBox="1"/>
           <p:nvPr/>
         </p:nvSpPr>
         <p:spPr>
           <a:xfrm>
-            <a:off x="457200" y="4754880"/>
-            <a:ext cx="11277295" cy="822960"/>
+            <a:off x="457200" y="5394960"/>
+            <a:ext cx="11277295" cy="1005840"/>
           </a:xfrm>
           <a:prstGeom prst="rect">
             <a:avLst/>
@@ -5603,47 +5644,6 @@
             </a:pPr>
             <a:r>
               <a:t>Axis tick labels are shown once here rather than repeated in tiny print on every one of the 6 scenario panels.</a:t>
-            </a:r>
-          </a:p>
-        </p:txBody>
-      </p:sp>
-      <p:sp>
-        <p:nvSpPr>
-          <p:cNvPr id="6" name="TextBox 5"/>
-          <p:cNvSpPr txBox="1"/>
-          <p:nvPr/>
-        </p:nvSpPr>
-        <p:spPr>
-          <a:xfrm>
-            <a:off x="548640" y="6263640"/>
-            <a:ext cx="11094415" cy="822960"/>
-          </a:xfrm>
-          <a:prstGeom prst="rect">
-            <a:avLst/>
-          </a:prstGeom>
-          <a:noFill/>
-        </p:spPr>
-        <p:txBody>
-          <a:bodyPr wrap="square">
-            <a:spAutoFit/>
-          </a:bodyPr>
-          <a:lstStyle/>
-          <a:p>
-            <a:r>
-              <a:rPr b="1" sz="1100">
-                <a:solidFill>
-                  <a:srgbClr val="1F2D3D"/>
-                </a:solidFill>
-              </a:rPr>
-              <a:t>Figure 7: </a:t>
-            </a:r>
-            <a:r>
-              <a:rPr i="1" sz="1100">
-                <a:solidFill>
-                  <a:srgbClr val="5A6A7A"/>
-                </a:solidFill>
-              </a:rPr>
-              <a:t>30-day runs. One panel per scenario; route constructors on the rows, selection × improver combinations on the columns.</a:t>
             </a:r>
           </a:p>
         </p:txBody>
@@ -5775,7 +5775,7 @@
         <p:spPr>
           <a:xfrm>
             <a:off x="548640" y="6355080"/>
-            <a:ext cx="11094415" cy="822960"/>
+            <a:ext cx="11643055" cy="822960"/>
           </a:xfrm>
           <a:prstGeom prst="rect">
             <a:avLst/>
@@ -5910,7 +5910,7 @@
         <p:spPr>
           <a:xfrm>
             <a:off x="548640" y="6355080"/>
-            <a:ext cx="11094415" cy="822960"/>
+            <a:ext cx="11643055" cy="822960"/>
           </a:xfrm>
           <a:prstGeom prst="rect">
             <a:avLst/>
@@ -6014,7 +6014,7 @@
       </p:sp>
       <p:pic>
         <p:nvPicPr>
-          <p:cNvPr id="3" name="Picture 2" descr="full_results_table.png"/>
+          <p:cNvPr id="3" name="Picture 2" descr="full_results_table_strategy_0.png"/>
           <p:cNvPicPr>
             <a:picLocks noChangeAspect="1"/>
           </p:cNvPicPr>
@@ -6028,17 +6028,65 @@
         </p:blipFill>
         <p:spPr>
           <a:xfrm>
-            <a:off x="274320" y="2869653"/>
-            <a:ext cx="11643055" cy="1301573"/>
+            <a:off x="2445602" y="1051560"/>
+            <a:ext cx="7300491" cy="1645919"/>
           </a:xfrm>
           <a:prstGeom prst="rect">
             <a:avLst/>
           </a:prstGeom>
         </p:spPr>
       </p:pic>
-      <p:sp>
-        <p:nvSpPr>
-          <p:cNvPr id="4" name="TextBox 3"/>
+      <p:pic>
+        <p:nvPicPr>
+          <p:cNvPr id="4" name="Picture 3" descr="full_results_table_strategy_1.png"/>
+          <p:cNvPicPr>
+            <a:picLocks noChangeAspect="1"/>
+          </p:cNvPicPr>
+          <p:nvPr/>
+        </p:nvPicPr>
+        <p:blipFill>
+          <a:blip r:embed="rId3"/>
+          <a:stretch>
+            <a:fillRect/>
+          </a:stretch>
+        </p:blipFill>
+        <p:spPr>
+          <a:xfrm>
+            <a:off x="2445602" y="2697480"/>
+            <a:ext cx="7300491" cy="1645919"/>
+          </a:xfrm>
+          <a:prstGeom prst="rect">
+            <a:avLst/>
+          </a:prstGeom>
+        </p:spPr>
+      </p:pic>
+      <p:pic>
+        <p:nvPicPr>
+          <p:cNvPr id="5" name="Picture 4" descr="full_results_table_strategy_2.png"/>
+          <p:cNvPicPr>
+            <a:picLocks noChangeAspect="1"/>
+          </p:cNvPicPr>
+          <p:nvPr/>
+        </p:nvPicPr>
+        <p:blipFill>
+          <a:blip r:embed="rId4"/>
+          <a:stretch>
+            <a:fillRect/>
+          </a:stretch>
+        </p:blipFill>
+        <p:spPr>
+          <a:xfrm>
+            <a:off x="2445602" y="4343400"/>
+            <a:ext cx="7300491" cy="1645919"/>
+          </a:xfrm>
+          <a:prstGeom prst="rect">
+            <a:avLst/>
+          </a:prstGeom>
+        </p:spPr>
+      </p:pic>
+      <p:sp>
+        <p:nvSpPr>
+          <p:cNvPr id="6" name="TextBox 5"/>
           <p:cNvSpPr txBox="1"/>
           <p:nvPr/>
         </p:nvSpPr>
@@ -6072,7 +6120,7 @@
                   <a:srgbClr val="5A6A7A"/>
                 </a:solidFill>
               </a:rPr>
-              <a:t>Full results table — rows: graph size × region × data distribution; columns: mandatory selection strategy × route constructor × route improver. In every cell, the top value is mean±std overflows (lower is better) and the bottom value is mean±std kg/km (higher is better); the best value per row is shown in bold green.</a:t>
+              <a:t>Full results table — rows: graph size × region × data distribution; columns: partitioned by mandatory selection strategy (LA, LM, SL), one partial table per value; each partial table then grouped by route constructor × route improver. In every cell, the top value is mean±std overflows (lower is better) and the bottom value is mean±std kg/km (higher is better); the best value per row is shown in bold green.</a:t>
             </a:r>
           </a:p>
         </p:txBody>

</xml_diff>